<commit_message>
doc improvements in sequence documentation
add lstm related QAs and fix in sequence pptx
</commit_message>
<xml_diff>
--- a/my_notes/sequence_models/Seq2Seq_Models_and_Attention_Visuals.pptx
+++ b/my_notes/sequence_models/Seq2Seq_Models_and_Attention_Visuals.pptx
@@ -6,10 +6,12 @@
   </p:sldMasterIdLst>
   <p:sldIdLst>
     <p:sldId id="257" r:id="rId2"/>
-    <p:sldId id="256" r:id="rId3"/>
-    <p:sldId id="259" r:id="rId4"/>
-    <p:sldId id="258" r:id="rId5"/>
-    <p:sldId id="260" r:id="rId6"/>
+    <p:sldId id="261" r:id="rId3"/>
+    <p:sldId id="262" r:id="rId4"/>
+    <p:sldId id="256" r:id="rId5"/>
+    <p:sldId id="259" r:id="rId6"/>
+    <p:sldId id="258" r:id="rId7"/>
+    <p:sldId id="260" r:id="rId8"/>
   </p:sldIdLst>
   <p:sldSz cx="12192000" cy="6858000"/>
   <p:notesSz cx="6858000" cy="9144000"/>
@@ -108,6 +110,11 @@
       </a:defRPr>
     </a:lvl9pPr>
   </p:defaultTextStyle>
+  <p:extLst>
+    <p:ext uri="{EFAFB233-063F-42B5-8137-9DF3F51BA10A}">
+      <p15:sldGuideLst xmlns:p15="http://schemas.microsoft.com/office/powerpoint/2012/main"/>
+    </p:ext>
+  </p:extLst>
 </p:presentation>
 </file>
 
@@ -260,7 +267,7 @@
           <a:p>
             <a:fld id="{4AE9EC84-D28E-5446-B16B-E1870A34CAC0}" type="datetimeFigureOut">
               <a:rPr lang="en-GR" smtClean="0"/>
-              <a:t>7/8/25</a:t>
+              <a:t>21/9/25</a:t>
             </a:fld>
             <a:endParaRPr lang="en-GR"/>
           </a:p>
@@ -460,7 +467,7 @@
           <a:p>
             <a:fld id="{4AE9EC84-D28E-5446-B16B-E1870A34CAC0}" type="datetimeFigureOut">
               <a:rPr lang="en-GR" smtClean="0"/>
-              <a:t>7/8/25</a:t>
+              <a:t>21/9/25</a:t>
             </a:fld>
             <a:endParaRPr lang="en-GR"/>
           </a:p>
@@ -670,7 +677,7 @@
           <a:p>
             <a:fld id="{4AE9EC84-D28E-5446-B16B-E1870A34CAC0}" type="datetimeFigureOut">
               <a:rPr lang="en-GR" smtClean="0"/>
-              <a:t>7/8/25</a:t>
+              <a:t>21/9/25</a:t>
             </a:fld>
             <a:endParaRPr lang="en-GR"/>
           </a:p>
@@ -870,7 +877,7 @@
           <a:p>
             <a:fld id="{4AE9EC84-D28E-5446-B16B-E1870A34CAC0}" type="datetimeFigureOut">
               <a:rPr lang="en-GR" smtClean="0"/>
-              <a:t>7/8/25</a:t>
+              <a:t>21/9/25</a:t>
             </a:fld>
             <a:endParaRPr lang="en-GR"/>
           </a:p>
@@ -1146,7 +1153,7 @@
           <a:p>
             <a:fld id="{4AE9EC84-D28E-5446-B16B-E1870A34CAC0}" type="datetimeFigureOut">
               <a:rPr lang="en-GR" smtClean="0"/>
-              <a:t>7/8/25</a:t>
+              <a:t>21/9/25</a:t>
             </a:fld>
             <a:endParaRPr lang="en-GR"/>
           </a:p>
@@ -1414,7 +1421,7 @@
           <a:p>
             <a:fld id="{4AE9EC84-D28E-5446-B16B-E1870A34CAC0}" type="datetimeFigureOut">
               <a:rPr lang="en-GR" smtClean="0"/>
-              <a:t>7/8/25</a:t>
+              <a:t>21/9/25</a:t>
             </a:fld>
             <a:endParaRPr lang="en-GR"/>
           </a:p>
@@ -1829,7 +1836,7 @@
           <a:p>
             <a:fld id="{4AE9EC84-D28E-5446-B16B-E1870A34CAC0}" type="datetimeFigureOut">
               <a:rPr lang="en-GR" smtClean="0"/>
-              <a:t>7/8/25</a:t>
+              <a:t>21/9/25</a:t>
             </a:fld>
             <a:endParaRPr lang="en-GR"/>
           </a:p>
@@ -1971,7 +1978,7 @@
           <a:p>
             <a:fld id="{4AE9EC84-D28E-5446-B16B-E1870A34CAC0}" type="datetimeFigureOut">
               <a:rPr lang="en-GR" smtClean="0"/>
-              <a:t>7/8/25</a:t>
+              <a:t>21/9/25</a:t>
             </a:fld>
             <a:endParaRPr lang="en-GR"/>
           </a:p>
@@ -2084,7 +2091,7 @@
           <a:p>
             <a:fld id="{4AE9EC84-D28E-5446-B16B-E1870A34CAC0}" type="datetimeFigureOut">
               <a:rPr lang="en-GR" smtClean="0"/>
-              <a:t>7/8/25</a:t>
+              <a:t>21/9/25</a:t>
             </a:fld>
             <a:endParaRPr lang="en-GR"/>
           </a:p>
@@ -2397,7 +2404,7 @@
           <a:p>
             <a:fld id="{4AE9EC84-D28E-5446-B16B-E1870A34CAC0}" type="datetimeFigureOut">
               <a:rPr lang="en-GR" smtClean="0"/>
-              <a:t>7/8/25</a:t>
+              <a:t>21/9/25</a:t>
             </a:fld>
             <a:endParaRPr lang="en-GR"/>
           </a:p>
@@ -2686,7 +2693,7 @@
           <a:p>
             <a:fld id="{4AE9EC84-D28E-5446-B16B-E1870A34CAC0}" type="datetimeFigureOut">
               <a:rPr lang="en-GR" smtClean="0"/>
-              <a:t>7/8/25</a:t>
+              <a:t>21/9/25</a:t>
             </a:fld>
             <a:endParaRPr lang="en-GR"/>
           </a:p>
@@ -2929,7 +2936,7 @@
           <a:p>
             <a:fld id="{4AE9EC84-D28E-5446-B16B-E1870A34CAC0}" type="datetimeFigureOut">
               <a:rPr lang="en-GR" smtClean="0"/>
-              <a:t>7/8/25</a:t>
+              <a:t>21/9/25</a:t>
             </a:fld>
             <a:endParaRPr lang="en-GR"/>
           </a:p>
@@ -4397,6 +4404,428 @@
           <a:chExt cx="0" cy="0"/>
         </a:xfrm>
       </p:grpSpPr>
+      <p:sp>
+        <p:nvSpPr>
+          <p:cNvPr id="4" name="TextBox 3">
+            <a:extLst>
+              <a:ext uri="{FF2B5EF4-FFF2-40B4-BE49-F238E27FC236}">
+                <a16:creationId xmlns:a16="http://schemas.microsoft.com/office/drawing/2014/main" id="{44EAE895-179D-414D-0CD9-5727E2A5C329}"/>
+              </a:ext>
+            </a:extLst>
+          </p:cNvPr>
+          <p:cNvSpPr txBox="1"/>
+          <p:nvPr/>
+        </p:nvSpPr>
+        <p:spPr>
+          <a:xfrm>
+            <a:off x="0" y="68271"/>
+            <a:ext cx="12191999" cy="523220"/>
+          </a:xfrm>
+          <a:prstGeom prst="rect">
+            <a:avLst/>
+          </a:prstGeom>
+          <a:noFill/>
+        </p:spPr>
+        <p:txBody>
+          <a:bodyPr wrap="square" rtlCol="0">
+            <a:spAutoFit/>
+          </a:bodyPr>
+          <a:lstStyle/>
+          <a:p>
+            <a:r>
+              <a:rPr lang="en-GB" sz="2800" dirty="0"/>
+              <a:t>Recurrent Networks (RNN, LSTM, GRU)</a:t>
+            </a:r>
+            <a:endParaRPr lang="en-GR" sz="2800" dirty="0"/>
+          </a:p>
+        </p:txBody>
+      </p:sp>
+      <p:pic>
+        <p:nvPicPr>
+          <p:cNvPr id="10" name="Picture 9">
+            <a:extLst>
+              <a:ext uri="{FF2B5EF4-FFF2-40B4-BE49-F238E27FC236}">
+                <a16:creationId xmlns:a16="http://schemas.microsoft.com/office/drawing/2014/main" id="{54BEA7BA-9A55-8342-D952-776029934119}"/>
+              </a:ext>
+            </a:extLst>
+          </p:cNvPr>
+          <p:cNvPicPr>
+            <a:picLocks noChangeAspect="1"/>
+          </p:cNvPicPr>
+          <p:nvPr/>
+        </p:nvPicPr>
+        <p:blipFill>
+          <a:blip r:embed="rId2"/>
+          <a:stretch>
+            <a:fillRect/>
+          </a:stretch>
+        </p:blipFill>
+        <p:spPr>
+          <a:xfrm>
+            <a:off x="5848198" y="591491"/>
+            <a:ext cx="5683402" cy="3614289"/>
+          </a:xfrm>
+          <a:prstGeom prst="rect">
+            <a:avLst/>
+          </a:prstGeom>
+          <a:ln>
+            <a:noFill/>
+          </a:ln>
+        </p:spPr>
+      </p:pic>
+      <p:pic>
+        <p:nvPicPr>
+          <p:cNvPr id="13" name="Picture 12">
+            <a:extLst>
+              <a:ext uri="{FF2B5EF4-FFF2-40B4-BE49-F238E27FC236}">
+                <a16:creationId xmlns:a16="http://schemas.microsoft.com/office/drawing/2014/main" id="{D21800A2-C6BB-EACF-ADD7-8DD7EE0CF4AB}"/>
+              </a:ext>
+            </a:extLst>
+          </p:cNvPr>
+          <p:cNvPicPr>
+            <a:picLocks noChangeAspect="1"/>
+          </p:cNvPicPr>
+          <p:nvPr/>
+        </p:nvPicPr>
+        <p:blipFill>
+          <a:blip r:embed="rId3"/>
+          <a:stretch>
+            <a:fillRect/>
+          </a:stretch>
+        </p:blipFill>
+        <p:spPr>
+          <a:xfrm>
+            <a:off x="133199" y="705839"/>
+            <a:ext cx="5537201" cy="2983092"/>
+          </a:xfrm>
+          <a:prstGeom prst="rect">
+            <a:avLst/>
+          </a:prstGeom>
+          <a:ln>
+            <a:noFill/>
+          </a:ln>
+        </p:spPr>
+      </p:pic>
+      <p:pic>
+        <p:nvPicPr>
+          <p:cNvPr id="14" name="Picture 13">
+            <a:extLst>
+              <a:ext uri="{FF2B5EF4-FFF2-40B4-BE49-F238E27FC236}">
+                <a16:creationId xmlns:a16="http://schemas.microsoft.com/office/drawing/2014/main" id="{06BD146B-DA18-9DA1-7D8B-7266D1AF50CC}"/>
+              </a:ext>
+            </a:extLst>
+          </p:cNvPr>
+          <p:cNvPicPr>
+            <a:picLocks noChangeAspect="1"/>
+          </p:cNvPicPr>
+          <p:nvPr/>
+        </p:nvPicPr>
+        <p:blipFill>
+          <a:blip r:embed="rId4"/>
+          <a:stretch>
+            <a:fillRect/>
+          </a:stretch>
+        </p:blipFill>
+        <p:spPr>
+          <a:xfrm>
+            <a:off x="133199" y="3688931"/>
+            <a:ext cx="5537201" cy="3022691"/>
+          </a:xfrm>
+          <a:prstGeom prst="rect">
+            <a:avLst/>
+          </a:prstGeom>
+          <a:ln>
+            <a:noFill/>
+          </a:ln>
+        </p:spPr>
+      </p:pic>
+      <p:pic>
+        <p:nvPicPr>
+          <p:cNvPr id="15" name="Picture 14">
+            <a:extLst>
+              <a:ext uri="{FF2B5EF4-FFF2-40B4-BE49-F238E27FC236}">
+                <a16:creationId xmlns:a16="http://schemas.microsoft.com/office/drawing/2014/main" id="{97EA837F-317D-3140-7A70-0B9E169C1F7E}"/>
+              </a:ext>
+            </a:extLst>
+          </p:cNvPr>
+          <p:cNvPicPr>
+            <a:picLocks noChangeAspect="1"/>
+          </p:cNvPicPr>
+          <p:nvPr/>
+        </p:nvPicPr>
+        <p:blipFill>
+          <a:blip r:embed="rId5"/>
+          <a:srcRect b="26962"/>
+          <a:stretch>
+            <a:fillRect/>
+          </a:stretch>
+        </p:blipFill>
+        <p:spPr>
+          <a:xfrm>
+            <a:off x="5848198" y="4383580"/>
+            <a:ext cx="5683402" cy="2207720"/>
+          </a:xfrm>
+          <a:prstGeom prst="rect">
+            <a:avLst/>
+          </a:prstGeom>
+          <a:ln>
+            <a:noFill/>
+          </a:ln>
+        </p:spPr>
+      </p:pic>
+    </p:spTree>
+    <p:extLst>
+      <p:ext uri="{BB962C8B-B14F-4D97-AF65-F5344CB8AC3E}">
+        <p14:creationId xmlns:p14="http://schemas.microsoft.com/office/powerpoint/2010/main" val="1576603261"/>
+      </p:ext>
+    </p:extLst>
+  </p:cSld>
+  <p:clrMapOvr>
+    <a:masterClrMapping/>
+  </p:clrMapOvr>
+</p:sld>
+</file>
+
+<file path=ppt/slides/slide3.xml><?xml version="1.0" encoding="utf-8"?>
+<p:sld xmlns:a="http://schemas.openxmlformats.org/drawingml/2006/main" xmlns:r="http://schemas.openxmlformats.org/officeDocument/2006/relationships" xmlns:p="http://schemas.openxmlformats.org/presentationml/2006/main">
+  <p:cSld>
+    <p:spTree>
+      <p:nvGrpSpPr>
+        <p:cNvPr id="1" name="">
+          <a:extLst>
+            <a:ext uri="{FF2B5EF4-FFF2-40B4-BE49-F238E27FC236}">
+              <a16:creationId xmlns:a16="http://schemas.microsoft.com/office/drawing/2014/main" id="{34E4EF12-3EE3-ACCE-6505-47526BBAFCC5}"/>
+            </a:ext>
+          </a:extLst>
+        </p:cNvPr>
+        <p:cNvGrpSpPr/>
+        <p:nvPr/>
+      </p:nvGrpSpPr>
+      <p:grpSpPr>
+        <a:xfrm>
+          <a:off x="0" y="0"/>
+          <a:ext cx="0" cy="0"/>
+          <a:chOff x="0" y="0"/>
+          <a:chExt cx="0" cy="0"/>
+        </a:xfrm>
+      </p:grpSpPr>
+      <p:sp>
+        <p:nvSpPr>
+          <p:cNvPr id="4" name="TextBox 3">
+            <a:extLst>
+              <a:ext uri="{FF2B5EF4-FFF2-40B4-BE49-F238E27FC236}">
+                <a16:creationId xmlns:a16="http://schemas.microsoft.com/office/drawing/2014/main" id="{2281FD94-2505-F165-C0EA-D484052E33A2}"/>
+              </a:ext>
+            </a:extLst>
+          </p:cNvPr>
+          <p:cNvSpPr txBox="1"/>
+          <p:nvPr/>
+        </p:nvSpPr>
+        <p:spPr>
+          <a:xfrm>
+            <a:off x="0" y="68271"/>
+            <a:ext cx="12191999" cy="523220"/>
+          </a:xfrm>
+          <a:prstGeom prst="rect">
+            <a:avLst/>
+          </a:prstGeom>
+          <a:noFill/>
+        </p:spPr>
+        <p:txBody>
+          <a:bodyPr wrap="square" rtlCol="0">
+            <a:spAutoFit/>
+          </a:bodyPr>
+          <a:lstStyle/>
+          <a:p>
+            <a:r>
+              <a:rPr lang="en-GB" sz="2800" dirty="0"/>
+              <a:t>Recurrent Networks (RNN, LSTM, GRU)</a:t>
+            </a:r>
+            <a:endParaRPr lang="en-GR" sz="2800" dirty="0"/>
+          </a:p>
+        </p:txBody>
+      </p:sp>
+      <p:pic>
+        <p:nvPicPr>
+          <p:cNvPr id="3" name="Picture 2">
+            <a:extLst>
+              <a:ext uri="{FF2B5EF4-FFF2-40B4-BE49-F238E27FC236}">
+                <a16:creationId xmlns:a16="http://schemas.microsoft.com/office/drawing/2014/main" id="{A8A4179E-4CD0-B20E-0F98-786B21270D70}"/>
+              </a:ext>
+            </a:extLst>
+          </p:cNvPr>
+          <p:cNvPicPr>
+            <a:picLocks noChangeAspect="1"/>
+          </p:cNvPicPr>
+          <p:nvPr/>
+        </p:nvPicPr>
+        <p:blipFill>
+          <a:blip r:embed="rId2"/>
+          <a:stretch>
+            <a:fillRect/>
+          </a:stretch>
+        </p:blipFill>
+        <p:spPr>
+          <a:xfrm>
+            <a:off x="37688" y="638682"/>
+            <a:ext cx="5943600" cy="1722349"/>
+          </a:xfrm>
+          <a:prstGeom prst="rect">
+            <a:avLst/>
+          </a:prstGeom>
+        </p:spPr>
+      </p:pic>
+      <p:pic>
+        <p:nvPicPr>
+          <p:cNvPr id="6" name="Picture 5">
+            <a:extLst>
+              <a:ext uri="{FF2B5EF4-FFF2-40B4-BE49-F238E27FC236}">
+                <a16:creationId xmlns:a16="http://schemas.microsoft.com/office/drawing/2014/main" id="{EE7CD449-9B44-DE83-33D8-4BE0BD6B9606}"/>
+              </a:ext>
+            </a:extLst>
+          </p:cNvPr>
+          <p:cNvPicPr>
+            <a:picLocks noChangeAspect="1"/>
+          </p:cNvPicPr>
+          <p:nvPr/>
+        </p:nvPicPr>
+        <p:blipFill>
+          <a:blip r:embed="rId3"/>
+          <a:stretch>
+            <a:fillRect/>
+          </a:stretch>
+        </p:blipFill>
+        <p:spPr>
+          <a:xfrm>
+            <a:off x="37688" y="2408221"/>
+            <a:ext cx="5943600" cy="1783080"/>
+          </a:xfrm>
+          <a:prstGeom prst="rect">
+            <a:avLst/>
+          </a:prstGeom>
+        </p:spPr>
+      </p:pic>
+      <p:pic>
+        <p:nvPicPr>
+          <p:cNvPr id="7" name="Picture 6" descr="Gated Recurrent Unit Networks - GeeksforGeeks">
+            <a:extLst>
+              <a:ext uri="{FF2B5EF4-FFF2-40B4-BE49-F238E27FC236}">
+                <a16:creationId xmlns:a16="http://schemas.microsoft.com/office/drawing/2014/main" id="{8A7B4BB2-7656-FAEC-2BEF-99FC5C2BB278}"/>
+              </a:ext>
+            </a:extLst>
+          </p:cNvPr>
+          <p:cNvPicPr>
+            <a:picLocks noChangeAspect="1"/>
+          </p:cNvPicPr>
+          <p:nvPr/>
+        </p:nvPicPr>
+        <p:blipFill>
+          <a:blip r:embed="rId4"/>
+          <a:srcRect l="13240" t="4877" r="15532" b="11673"/>
+          <a:stretch>
+            <a:fillRect/>
+          </a:stretch>
+        </p:blipFill>
+        <p:spPr>
+          <a:xfrm>
+            <a:off x="6818811" y="248776"/>
+            <a:ext cx="4636877" cy="2716225"/>
+          </a:xfrm>
+          <a:prstGeom prst="rect">
+            <a:avLst/>
+          </a:prstGeom>
+        </p:spPr>
+      </p:pic>
+      <p:pic>
+        <p:nvPicPr>
+          <p:cNvPr id="8" name="Picture 7" descr="RNN vs. LSTM vs. GRU | PyTorch">
+            <a:extLst>
+              <a:ext uri="{FF2B5EF4-FFF2-40B4-BE49-F238E27FC236}">
+                <a16:creationId xmlns:a16="http://schemas.microsoft.com/office/drawing/2014/main" id="{BB7AC551-DC1C-3173-AB2D-A5352E303511}"/>
+              </a:ext>
+            </a:extLst>
+          </p:cNvPr>
+          <p:cNvPicPr>
+            <a:picLocks noChangeAspect="1"/>
+          </p:cNvPicPr>
+          <p:nvPr/>
+        </p:nvPicPr>
+        <p:blipFill>
+          <a:blip r:embed="rId5"/>
+          <a:stretch>
+            <a:fillRect/>
+          </a:stretch>
+        </p:blipFill>
+        <p:spPr>
+          <a:xfrm>
+            <a:off x="5762484" y="3145506"/>
+            <a:ext cx="6429516" cy="2472475"/>
+          </a:xfrm>
+          <a:prstGeom prst="rect">
+            <a:avLst/>
+          </a:prstGeom>
+        </p:spPr>
+      </p:pic>
+      <p:pic>
+        <p:nvPicPr>
+          <p:cNvPr id="9" name="Picture 8" descr="Guide to RNNs, GRUs and LSTMs with diagrams and equations | by Bobby Cheng  | Medium">
+            <a:extLst>
+              <a:ext uri="{FF2B5EF4-FFF2-40B4-BE49-F238E27FC236}">
+                <a16:creationId xmlns:a16="http://schemas.microsoft.com/office/drawing/2014/main" id="{8429164F-104D-DED8-1114-5836AC3F3D88}"/>
+              </a:ext>
+            </a:extLst>
+          </p:cNvPr>
+          <p:cNvPicPr>
+            <a:picLocks noChangeAspect="1"/>
+          </p:cNvPicPr>
+          <p:nvPr/>
+        </p:nvPicPr>
+        <p:blipFill>
+          <a:blip r:embed="rId6"/>
+          <a:stretch>
+            <a:fillRect/>
+          </a:stretch>
+        </p:blipFill>
+        <p:spPr>
+          <a:xfrm>
+            <a:off x="489122" y="4020400"/>
+            <a:ext cx="4082877" cy="2837600"/>
+          </a:xfrm>
+          <a:prstGeom prst="rect">
+            <a:avLst/>
+          </a:prstGeom>
+        </p:spPr>
+      </p:pic>
+    </p:spTree>
+    <p:extLst>
+      <p:ext uri="{BB962C8B-B14F-4D97-AF65-F5344CB8AC3E}">
+        <p14:creationId xmlns:p14="http://schemas.microsoft.com/office/powerpoint/2010/main" val="1168125641"/>
+      </p:ext>
+    </p:extLst>
+  </p:cSld>
+  <p:clrMapOvr>
+    <a:masterClrMapping/>
+  </p:clrMapOvr>
+</p:sld>
+</file>
+
+<file path=ppt/slides/slide4.xml><?xml version="1.0" encoding="utf-8"?>
+<p:sld xmlns:a="http://schemas.openxmlformats.org/drawingml/2006/main" xmlns:r="http://schemas.openxmlformats.org/officeDocument/2006/relationships" xmlns:p="http://schemas.openxmlformats.org/presentationml/2006/main">
+  <p:cSld>
+    <p:spTree>
+      <p:nvGrpSpPr>
+        <p:cNvPr id="1" name=""/>
+        <p:cNvGrpSpPr/>
+        <p:nvPr/>
+      </p:nvGrpSpPr>
+      <p:grpSpPr>
+        <a:xfrm>
+          <a:off x="0" y="0"/>
+          <a:ext cx="0" cy="0"/>
+          <a:chOff x="0" y="0"/>
+          <a:chExt cx="0" cy="0"/>
+        </a:xfrm>
+      </p:grpSpPr>
       <p:pic>
         <p:nvPicPr>
           <p:cNvPr id="5" name="Picture 4">
@@ -4475,7 +4904,7 @@
 </p:sld>
 </file>
 
-<file path=ppt/slides/slide3.xml><?xml version="1.0" encoding="utf-8"?>
+<file path=ppt/slides/slide5.xml><?xml version="1.0" encoding="utf-8"?>
 <p:sld xmlns:a="http://schemas.openxmlformats.org/drawingml/2006/main" xmlns:r="http://schemas.openxmlformats.org/officeDocument/2006/relationships" xmlns:p="http://schemas.openxmlformats.org/presentationml/2006/main">
   <p:cSld>
     <p:spTree>
@@ -4587,7 +5016,7 @@
 </p:sld>
 </file>
 
-<file path=ppt/slides/slide4.xml><?xml version="1.0" encoding="utf-8"?>
+<file path=ppt/slides/slide6.xml><?xml version="1.0" encoding="utf-8"?>
 <p:sld xmlns:a="http://schemas.openxmlformats.org/drawingml/2006/main" xmlns:r="http://schemas.openxmlformats.org/officeDocument/2006/relationships" xmlns:p="http://schemas.openxmlformats.org/presentationml/2006/main">
   <p:cSld>
     <p:spTree>
@@ -4711,7 +5140,7 @@
 </p:sld>
 </file>
 
-<file path=ppt/slides/slide5.xml><?xml version="1.0" encoding="utf-8"?>
+<file path=ppt/slides/slide7.xml><?xml version="1.0" encoding="utf-8"?>
 <p:sld xmlns:a="http://schemas.openxmlformats.org/drawingml/2006/main" xmlns:r="http://schemas.openxmlformats.org/officeDocument/2006/relationships" xmlns:p="http://schemas.openxmlformats.org/presentationml/2006/main">
   <p:cSld>
     <p:spTree>

</xml_diff>